<commit_message>
update report hub drag and drop
</commit_message>
<xml_diff>
--- a/docs/marketing/Turas demo companion.pptx
+++ b/docs/marketing/Turas demo companion.pptx
@@ -9346,9 +9346,27 @@
                 <a:ea typeface="Calibri" pitchFamily="34" charset="-122"/>
                 <a:cs typeface="Calibri" pitchFamily="34" charset="-120"/>
               </a:rPr>
-              <a:t>Send us an existing dataset — even an old one — and we’ll run it through Turas so you can see your data in an interactive report.</a:t>
-            </a:r>
-            <a:endParaRPr lang="en-US" sz="1467" dirty="0"/>
+              <a:t>Send us an existing dataset — even an old one — and we’ll run it through Turas so you can see your data in an interactive report. </a:t>
+            </a:r>
+          </a:p>
+          <a:p>
+            <a:pPr>
+              <a:lnSpc>
+                <a:spcPct val="130000"/>
+              </a:lnSpc>
+            </a:pPr>
+            <a:r>
+              <a:rPr lang="en-US" sz="1100" dirty="0">
+                <a:solidFill>
+                  <a:srgbClr val="5A6078"/>
+                </a:solidFill>
+                <a:latin typeface="Calibri" pitchFamily="34" charset="0"/>
+                <a:ea typeface="Calibri" pitchFamily="34" charset="-122"/>
+                <a:cs typeface="Calibri" pitchFamily="34" charset="-120"/>
+              </a:rPr>
+              <a:t>*subject to data in a usable format</a:t>
+            </a:r>
+            <a:endParaRPr lang="en-US" sz="1100" dirty="0"/>
           </a:p>
         </p:txBody>
       </p:sp>
@@ -9750,7 +9768,7 @@
                 <a:ea typeface="Calibri" pitchFamily="34" charset="-122"/>
                 <a:cs typeface="Calibri" pitchFamily="34" charset="-120"/>
               </a:rPr>
-              <a:t>We can set up a broader session for colleagues who need to see it. Or share the one-pager and let them come to us.</a:t>
+              <a:t>We can set up a broader session for colleagues who need to see it. </a:t>
             </a:r>
             <a:endParaRPr lang="en-US" sz="1467" dirty="0"/>
           </a:p>

</xml_diff>